<commit_message>
0809 decks: add WD block-by-block detail slides (detection/confirmation stages) and Poteshman 2026 related-work comparison slide (kor+eng); clip overflowing caption on kor final-fit slide
Co-Authored-By: Claude Fable 5 <noreply@anthropic.com>
</commit_message>
<xml_diff>
--- a/results/NV_C13_summary_0809_eng.pptx
+++ b/results/NV_C13_summary_0809_eng.pptx
@@ -8,6 +8,9 @@
     <p:sldId id="266" r:id="rId2"/>
     <p:sldId id="267" r:id="rId3"/>
     <p:sldId id="268" r:id="rId4"/>
+    <p:sldId id="277" r:id="rId15"/>
+    <p:sldId id="278" r:id="rId16"/>
+    <p:sldId id="279" r:id="rId17"/>
     <p:sldId id="269" r:id="rId5"/>
     <p:sldId id="270" r:id="rId6"/>
     <p:sldId id="271" r:id="rId7"/>
@@ -4923,6 +4926,1910 @@
         <p14:creationId xmlns:p14="http://schemas.microsoft.com/office/powerpoint/2010/main" val="2513006826"/>
       </p:ext>
     </p:extLst>
+  </p:cSld>
+  <p:clrMapOvr>
+    <a:masterClrMapping/>
+  </p:clrMapOvr>
+</p:sld>
+</file>
+
+<file path=ppt/slides/slide10.xml><?xml version="1.0" encoding="utf-8"?>
+<p:sld xmlns:a="http://schemas.openxmlformats.org/drawingml/2006/main" xmlns:p="http://schemas.openxmlformats.org/presentationml/2006/main" xmlns:r="http://schemas.openxmlformats.org/officeDocument/2006/relationships">
+  <p:cSld>
+    <p:spTree>
+      <p:nvGrpSpPr>
+        <p:cNvPr id="1" name=""/>
+        <p:cNvGrpSpPr/>
+        <p:nvPr/>
+      </p:nvGrpSpPr>
+      <p:grpSpPr/>
+      <p:sp>
+        <p:nvSpPr>
+          <p:cNvPr id="2" name="TextBox 1"/>
+          <p:cNvSpPr txBox="1"/>
+          <p:nvPr/>
+        </p:nvSpPr>
+        <p:spPr>
+          <a:xfrm>
+            <a:off x="320040" y="164592"/>
+            <a:ext cx="11521440" cy="548640"/>
+          </a:xfrm>
+          <a:prstGeom prst="rect">
+            <a:avLst/>
+          </a:prstGeom>
+          <a:noFill/>
+        </p:spPr>
+        <p:txBody>
+          <a:bodyPr wrap="none">
+            <a:spAutoFit/>
+          </a:bodyPr>
+          <a:lstStyle/>
+          <a:p>
+            <a:pPr>
+              <a:defRPr sz="2400" b="1"/>
+            </a:pPr>
+            <a:r>
+              <a:t>WD Method in Detail ① — Detection Stage (Neural): Blocks 1–4</a:t>
+            </a:r>
+          </a:p>
+        </p:txBody>
+      </p:sp>
+      <p:sp>
+        <p:nvSpPr>
+          <p:cNvPr id="3" name="TextBox 2"/>
+          <p:cNvSpPr txBox="1"/>
+          <p:nvPr/>
+        </p:nvSpPr>
+        <p:spPr>
+          <a:xfrm>
+            <a:off x="320040" y="713232"/>
+            <a:ext cx="11521440" cy="365760"/>
+          </a:xfrm>
+          <a:prstGeom prst="rect">
+            <a:avLst/>
+          </a:prstGeom>
+          <a:noFill/>
+        </p:spPr>
+        <p:txBody>
+          <a:bodyPr wrap="none">
+            <a:spAutoFit/>
+          </a:bodyPr>
+          <a:lstStyle/>
+          <a:p>
+            <a:pPr>
+              <a:defRPr sz="1300" b="1">
+                <a:solidFill>
+                  <a:srgbClr val="B45000"/>
+                </a:solidFill>
+              </a:defRPr>
+            </a:pPr>
+            <a:r>
+              <a:t>▶ Key idea: 'stand up 61 period hypotheses at once, let them confer, keep only the real ones'</a:t>
+            </a:r>
+          </a:p>
+        </p:txBody>
+      </p:sp>
+      <p:sp>
+        <p:nvSpPr>
+          <p:cNvPr id="4" name="Rounded Rectangle 3"/>
+          <p:cNvSpPr/>
+          <p:nvPr/>
+        </p:nvSpPr>
+        <p:spPr>
+          <a:xfrm>
+            <a:off x="320040" y="1188720"/>
+            <a:ext cx="2816352" cy="5029200"/>
+          </a:xfrm>
+          <a:prstGeom prst="roundRect">
+            <a:avLst/>
+          </a:prstGeom>
+          <a:solidFill>
+            <a:srgbClr val="DBE9F8"/>
+          </a:solidFill>
+          <a:ln>
+            <a:solidFill>
+              <a:srgbClr val="666666"/>
+            </a:solidFill>
+          </a:ln>
+        </p:spPr>
+        <p:style>
+          <a:lnRef idx="1">
+            <a:schemeClr val="accent1"/>
+          </a:lnRef>
+          <a:fillRef idx="3">
+            <a:schemeClr val="accent1"/>
+          </a:fillRef>
+          <a:effectRef idx="2">
+            <a:schemeClr val="accent1"/>
+          </a:effectRef>
+          <a:fontRef idx="minor">
+            <a:schemeClr val="lt1"/>
+          </a:fontRef>
+        </p:style>
+        <p:txBody>
+          <a:bodyPr rtlCol="0" anchor="ctr" wrap="square" lIns="73152" rIns="73152" tIns="36576" bIns="36576"/>
+          <a:lstStyle/>
+          <a:p>
+            <a:pPr algn="l">
+              <a:defRPr sz="1200" b="1">
+                <a:solidFill>
+                  <a:srgbClr val="1A1A1A"/>
+                </a:solidFill>
+              </a:defRPr>
+            </a:pPr>
+            <a:r>
+              <a:t>① Input: 3-channel CPMG signal  (3×700)</a:t>
+            </a:r>
+          </a:p>
+          <a:p>
+            <a:pPr>
+              <a:defRPr sz="950">
+                <a:solidFill>
+                  <a:srgbClr val="262626"/>
+                </a:solidFill>
+              </a:defRPr>
+            </a:pPr>
+            <a:r>
+              <a:t>M(τ) from the N=8/16/20 measurements enters together</a:t>
+            </a:r>
+          </a:p>
+          <a:p>
+            <a:pPr>
+              <a:defRPr sz="950">
+                <a:solidFill>
+                  <a:srgbClr val="262626"/>
+                </a:solidFill>
+              </a:defRPr>
+            </a:pPr>
+            <a:r>
+              <a:t>Divided by the envelope (Eq.5 stretched-exp) to remove decay</a:t>
+            </a:r>
+          </a:p>
+          <a:p>
+            <a:pPr>
+              <a:defRPr sz="950">
+                <a:solidFill>
+                  <a:srgbClr val="262626"/>
+                </a:solidFill>
+              </a:defRPr>
+            </a:pPr>
+            <a:r>
+              <a:t>Why 3 channels: a real spin shifts its dips with N following physics</a:t>
+            </a:r>
+          </a:p>
+          <a:p>
+            <a:pPr>
+              <a:defRPr sz="950">
+                <a:solidFill>
+                  <a:srgbClr val="262626"/>
+                </a:solidFill>
+              </a:defRPr>
+            </a:pPr>
+            <a:r>
+              <a:t>→ the decisive cue separating real spins from noise dips</a:t>
+            </a:r>
+          </a:p>
+        </p:txBody>
+      </p:sp>
+      <p:sp>
+        <p:nvSpPr>
+          <p:cNvPr id="5" name="Right Arrow 4"/>
+          <p:cNvSpPr/>
+          <p:nvPr/>
+        </p:nvSpPr>
+        <p:spPr>
+          <a:xfrm>
+            <a:off x="3127248" y="3611879"/>
+            <a:ext cx="128015" cy="182880"/>
+          </a:xfrm>
+          <a:prstGeom prst="rightArrow">
+            <a:avLst/>
+          </a:prstGeom>
+          <a:solidFill>
+            <a:srgbClr val="888888"/>
+          </a:solidFill>
+          <a:ln>
+            <a:noFill/>
+          </a:ln>
+        </p:spPr>
+        <p:style>
+          <a:lnRef idx="1">
+            <a:schemeClr val="accent1"/>
+          </a:lnRef>
+          <a:fillRef idx="3">
+            <a:schemeClr val="accent1"/>
+          </a:fillRef>
+          <a:effectRef idx="2">
+            <a:schemeClr val="accent1"/>
+          </a:effectRef>
+          <a:fontRef idx="minor">
+            <a:schemeClr val="lt1"/>
+          </a:fontRef>
+        </p:style>
+        <p:txBody>
+          <a:bodyPr rtlCol="0" anchor="ctr"/>
+          <a:lstStyle/>
+          <a:p>
+            <a:pPr algn="ctr"/>
+          </a:p>
+        </p:txBody>
+      </p:sp>
+      <p:sp>
+        <p:nvSpPr>
+          <p:cNvPr id="6" name="Rounded Rectangle 5"/>
+          <p:cNvSpPr/>
+          <p:nvPr/>
+        </p:nvSpPr>
+        <p:spPr>
+          <a:xfrm>
+            <a:off x="3246120" y="1188720"/>
+            <a:ext cx="2816352" cy="5029200"/>
+          </a:xfrm>
+          <a:prstGeom prst="roundRect">
+            <a:avLst/>
+          </a:prstGeom>
+          <a:solidFill>
+            <a:srgbClr val="DBE9F8"/>
+          </a:solidFill>
+          <a:ln>
+            <a:solidFill>
+              <a:srgbClr val="666666"/>
+            </a:solidFill>
+          </a:ln>
+        </p:spPr>
+        <p:style>
+          <a:lnRef idx="1">
+            <a:schemeClr val="accent1"/>
+          </a:lnRef>
+          <a:fillRef idx="3">
+            <a:schemeClr val="accent1"/>
+          </a:fillRef>
+          <a:effectRef idx="2">
+            <a:schemeClr val="accent1"/>
+          </a:effectRef>
+          <a:fontRef idx="minor">
+            <a:schemeClr val="lt1"/>
+          </a:fontRef>
+        </p:style>
+        <p:txBody>
+          <a:bodyPr rtlCol="0" anchor="ctr" wrap="square" lIns="73152" rIns="73152" tIns="36576" bIns="36576"/>
+          <a:lstStyle/>
+          <a:p>
+            <a:pPr algn="l">
+              <a:defRPr sz="1200" b="1">
+                <a:solidFill>
+                  <a:srgbClr val="1A1A1A"/>
+                </a:solidFill>
+              </a:defRPr>
+            </a:pPr>
+            <a:r>
+              <a:t>② 61-window folding → tokens  (61,3,13,53)</a:t>
+            </a:r>
+          </a:p>
+          <a:p>
+            <a:pPr>
+              <a:defRPr sz="950">
+                <a:solidFill>
+                  <a:srgbClr val="262626"/>
+                </a:solidFill>
+              </a:defRPr>
+            </a:pPr>
+            <a:r>
+              <a:t>For each of 61 candidate A∥ (−60…+60 kHz, 2 kHz steps),</a:t>
+            </a:r>
+          </a:p>
+          <a:p>
+            <a:pPr>
+              <a:defRPr sz="950">
+                <a:solidFill>
+                  <a:srgbClr val="262626"/>
+                </a:solidFill>
+              </a:defRPr>
+            </a:pPr>
+            <a:r>
+              <a:t>fold the signal at that A's target period T_P(A) into a 13×53 image</a:t>
+            </a:r>
+          </a:p>
+          <a:p>
+            <a:pPr>
+              <a:defRPr sz="950">
+                <a:solidFill>
+                  <a:srgbClr val="262626"/>
+                </a:solidFill>
+              </a:defRPr>
+            </a:pPr>
+            <a:r>
+              <a:t>Right period → dips align as vertical stripes; wrong → scattered</a:t>
+            </a:r>
+          </a:p>
+          <a:p>
+            <a:pPr>
+              <a:defRPr sz="950">
+                <a:solidFill>
+                  <a:srgbClr val="262626"/>
+                </a:solidFill>
+              </a:defRPr>
+            </a:pPr>
+            <a:r>
+              <a:t>(same folding as 2021) → 61 hypotheses stood up in parallel</a:t>
+            </a:r>
+          </a:p>
+        </p:txBody>
+      </p:sp>
+      <p:sp>
+        <p:nvSpPr>
+          <p:cNvPr id="7" name="Right Arrow 6"/>
+          <p:cNvSpPr/>
+          <p:nvPr/>
+        </p:nvSpPr>
+        <p:spPr>
+          <a:xfrm>
+            <a:off x="6053328" y="3611879"/>
+            <a:ext cx="128015" cy="182880"/>
+          </a:xfrm>
+          <a:prstGeom prst="rightArrow">
+            <a:avLst/>
+          </a:prstGeom>
+          <a:solidFill>
+            <a:srgbClr val="888888"/>
+          </a:solidFill>
+          <a:ln>
+            <a:noFill/>
+          </a:ln>
+        </p:spPr>
+        <p:style>
+          <a:lnRef idx="1">
+            <a:schemeClr val="accent1"/>
+          </a:lnRef>
+          <a:fillRef idx="3">
+            <a:schemeClr val="accent1"/>
+          </a:fillRef>
+          <a:effectRef idx="2">
+            <a:schemeClr val="accent1"/>
+          </a:effectRef>
+          <a:fontRef idx="minor">
+            <a:schemeClr val="lt1"/>
+          </a:fontRef>
+        </p:style>
+        <p:txBody>
+          <a:bodyPr rtlCol="0" anchor="ctr"/>
+          <a:lstStyle/>
+          <a:p>
+            <a:pPr algn="ctr"/>
+          </a:p>
+        </p:txBody>
+      </p:sp>
+      <p:sp>
+        <p:nvSpPr>
+          <p:cNvPr id="8" name="Rounded Rectangle 7"/>
+          <p:cNvSpPr/>
+          <p:nvPr/>
+        </p:nvSpPr>
+        <p:spPr>
+          <a:xfrm>
+            <a:off x="6172200" y="1188720"/>
+            <a:ext cx="2816352" cy="5029200"/>
+          </a:xfrm>
+          <a:prstGeom prst="roundRect">
+            <a:avLst/>
+          </a:prstGeom>
+          <a:solidFill>
+            <a:srgbClr val="D9EAD3"/>
+          </a:solidFill>
+          <a:ln>
+            <a:solidFill>
+              <a:srgbClr val="666666"/>
+            </a:solidFill>
+          </a:ln>
+        </p:spPr>
+        <p:style>
+          <a:lnRef idx="1">
+            <a:schemeClr val="accent1"/>
+          </a:lnRef>
+          <a:fillRef idx="3">
+            <a:schemeClr val="accent1"/>
+          </a:fillRef>
+          <a:effectRef idx="2">
+            <a:schemeClr val="accent1"/>
+          </a:effectRef>
+          <a:fontRef idx="minor">
+            <a:schemeClr val="lt1"/>
+          </a:fontRef>
+        </p:style>
+        <p:txBody>
+          <a:bodyPr rtlCol="0" anchor="ctr" wrap="square" lIns="73152" rIns="73152" tIns="36576" bIns="36576"/>
+          <a:lstStyle/>
+          <a:p>
+            <a:pPr algn="l">
+              <a:defRPr sz="1200" b="1">
+                <a:solidFill>
+                  <a:srgbClr val="1A1A1A"/>
+                </a:solidFill>
+              </a:defRPr>
+            </a:pPr>
+            <a:r>
+              <a:t>③ Shared CNN embedding + attention ×4</a:t>
+            </a:r>
+          </a:p>
+          <a:p>
+            <a:pPr>
+              <a:defRPr sz="950">
+                <a:solidFill>
+                  <a:srgbClr val="262626"/>
+                </a:solidFill>
+              </a:defRPr>
+            </a:pPr>
+            <a:r>
+              <a:t>Shared CNN: each token (3×13×53) compressed to one vector</a:t>
+            </a:r>
+          </a:p>
+          <a:p>
+            <a:pPr>
+              <a:defRPr sz="950">
+                <a:solidFill>
+                  <a:srgbClr val="262626"/>
+                </a:solidFill>
+              </a:defRPr>
+            </a:pPr>
+            <a:r>
+              <a:t>— all 61 windows share one CNN, so 'aligned' is judged uniformly</a:t>
+            </a:r>
+          </a:p>
+          <a:p>
+            <a:pPr>
+              <a:defRPr sz="950">
+                <a:solidFill>
+                  <a:srgbClr val="262626"/>
+                </a:solidFill>
+              </a:defRPr>
+            </a:pPr>
+            <a:r>
+              <a:t>4 attention layers: windows cross-reference each other ('confer')</a:t>
+            </a:r>
+          </a:p>
+          <a:p>
+            <a:pPr>
+              <a:defRPr sz="950">
+                <a:solidFill>
+                  <a:srgbClr val="262626"/>
+                </a:solidFill>
+              </a:defRPr>
+            </a:pPr>
+            <a:r>
+              <a:t>— joint excitement (continuous high-prob interval / harmonics)</a:t>
+            </a:r>
+          </a:p>
+          <a:p>
+            <a:pPr>
+              <a:defRPr sz="950">
+                <a:solidFill>
+                  <a:srgbClr val="262626"/>
+                </a:solidFill>
+              </a:defRPr>
+            </a:pPr>
+            <a:r>
+              <a:t>  is resolved by context → removes 2021's isolated-MLP false alarms</a:t>
+            </a:r>
+          </a:p>
+        </p:txBody>
+      </p:sp>
+      <p:sp>
+        <p:nvSpPr>
+          <p:cNvPr id="9" name="Right Arrow 8"/>
+          <p:cNvSpPr/>
+          <p:nvPr/>
+        </p:nvSpPr>
+        <p:spPr>
+          <a:xfrm>
+            <a:off x="8979408" y="3611879"/>
+            <a:ext cx="128015" cy="182880"/>
+          </a:xfrm>
+          <a:prstGeom prst="rightArrow">
+            <a:avLst/>
+          </a:prstGeom>
+          <a:solidFill>
+            <a:srgbClr val="888888"/>
+          </a:solidFill>
+          <a:ln>
+            <a:noFill/>
+          </a:ln>
+        </p:spPr>
+        <p:style>
+          <a:lnRef idx="1">
+            <a:schemeClr val="accent1"/>
+          </a:lnRef>
+          <a:fillRef idx="3">
+            <a:schemeClr val="accent1"/>
+          </a:fillRef>
+          <a:effectRef idx="2">
+            <a:schemeClr val="accent1"/>
+          </a:effectRef>
+          <a:fontRef idx="minor">
+            <a:schemeClr val="lt1"/>
+          </a:fontRef>
+        </p:style>
+        <p:txBody>
+          <a:bodyPr rtlCol="0" anchor="ctr"/>
+          <a:lstStyle/>
+          <a:p>
+            <a:pPr algn="ctr"/>
+          </a:p>
+        </p:txBody>
+      </p:sp>
+      <p:sp>
+        <p:nvSpPr>
+          <p:cNvPr id="10" name="Rounded Rectangle 9"/>
+          <p:cNvSpPr/>
+          <p:nvPr/>
+        </p:nvSpPr>
+        <p:spPr>
+          <a:xfrm>
+            <a:off x="9098280" y="1188720"/>
+            <a:ext cx="2816352" cy="5029200"/>
+          </a:xfrm>
+          <a:prstGeom prst="roundRect">
+            <a:avLst/>
+          </a:prstGeom>
+          <a:solidFill>
+            <a:srgbClr val="F9E3B3"/>
+          </a:solidFill>
+          <a:ln>
+            <a:solidFill>
+              <a:srgbClr val="666666"/>
+            </a:solidFill>
+          </a:ln>
+        </p:spPr>
+        <p:style>
+          <a:lnRef idx="1">
+            <a:schemeClr val="accent1"/>
+          </a:lnRef>
+          <a:fillRef idx="3">
+            <a:schemeClr val="accent1"/>
+          </a:fillRef>
+          <a:effectRef idx="2">
+            <a:schemeClr val="accent1"/>
+          </a:effectRef>
+          <a:fontRef idx="minor">
+            <a:schemeClr val="lt1"/>
+          </a:fontRef>
+        </p:style>
+        <p:txBody>
+          <a:bodyPr rtlCol="0" anchor="ctr" wrap="square" lIns="73152" rIns="73152" tIns="36576" bIns="36576"/>
+          <a:lstStyle/>
+          <a:p>
+            <a:pPr algn="l">
+              <a:defRPr sz="1200" b="1">
+                <a:solidFill>
+                  <a:srgbClr val="1A1A1A"/>
+                </a:solidFill>
+              </a:defRPr>
+            </a:pPr>
+            <a:r>
+              <a:t>④ Output: P(spin) curve → candidate regions</a:t>
+            </a:r>
+          </a:p>
+          <a:p>
+            <a:pPr>
+              <a:defRPr sz="950">
+                <a:solidFill>
+                  <a:srgbClr val="262626"/>
+                </a:solidFill>
+              </a:defRPr>
+            </a:pPr>
+            <a:r>
+              <a:t>61 per-window probabilities → contiguous p&gt;0.35 runs merged</a:t>
+            </a:r>
+          </a:p>
+          <a:p>
+            <a:pPr>
+              <a:defRPr sz="950">
+                <a:solidFill>
+                  <a:srgbClr val="262626"/>
+                </a:solidFill>
+              </a:defRPr>
+            </a:pPr>
+            <a:r>
+              <a:t>Output = candidate regions [lo, hi] (e.g. [−6,+12], [+40,+46] on NV1)</a:t>
+            </a:r>
+          </a:p>
+          <a:p>
+            <a:pPr>
+              <a:defRPr sz="950">
+                <a:solidFill>
+                  <a:srgbClr val="262626"/>
+                </a:solidFill>
+              </a:defRPr>
+            </a:pPr>
+            <a:r>
+              <a:t>This stage only decides where to dig —</a:t>
+            </a:r>
+          </a:p>
+          <a:p>
+            <a:pPr>
+              <a:defRPr sz="950">
+                <a:solidFill>
+                  <a:srgbClr val="262626"/>
+                </a:solidFill>
+              </a:defRPr>
+            </a:pPr>
+            <a:r>
+              <a:t>count and exact (A∥,A⊥) are left to the physics-fitting stage</a:t>
+            </a:r>
+          </a:p>
+        </p:txBody>
+      </p:sp>
+      <p:sp>
+        <p:nvSpPr>
+          <p:cNvPr id="11" name="TextBox 10"/>
+          <p:cNvSpPr txBox="1"/>
+          <p:nvPr/>
+        </p:nvSpPr>
+        <p:spPr>
+          <a:xfrm>
+            <a:off x="320040" y="6419088"/>
+            <a:ext cx="11521440" cy="384048"/>
+          </a:xfrm>
+          <a:prstGeom prst="rect">
+            <a:avLst/>
+          </a:prstGeom>
+          <a:noFill/>
+        </p:spPr>
+        <p:txBody>
+          <a:bodyPr wrap="square">
+            <a:spAutoFit/>
+          </a:bodyPr>
+          <a:lstStyle/>
+          <a:p>
+            <a:pPr>
+              <a:defRPr sz="1000">
+                <a:solidFill>
+                  <a:srgbClr val="404040"/>
+                </a:solidFill>
+              </a:defRPr>
+            </a:pPr>
+            <a:r>
+              <a:t>Block ② uses the same folding as 2021; the decisive difference is ③, where one model sees all 61 windows together — the root of 0 false alarms at room temperature</a:t>
+            </a:r>
+          </a:p>
+        </p:txBody>
+      </p:sp>
+    </p:spTree>
+  </p:cSld>
+  <p:clrMapOvr>
+    <a:masterClrMapping/>
+  </p:clrMapOvr>
+</p:sld>
+</file>
+
+<file path=ppt/slides/slide11.xml><?xml version="1.0" encoding="utf-8"?>
+<p:sld xmlns:a="http://schemas.openxmlformats.org/drawingml/2006/main" xmlns:p="http://schemas.openxmlformats.org/presentationml/2006/main" xmlns:r="http://schemas.openxmlformats.org/officeDocument/2006/relationships">
+  <p:cSld>
+    <p:spTree>
+      <p:nvGrpSpPr>
+        <p:cNvPr id="1" name=""/>
+        <p:cNvGrpSpPr/>
+        <p:nvPr/>
+      </p:nvGrpSpPr>
+      <p:grpSpPr/>
+      <p:sp>
+        <p:nvSpPr>
+          <p:cNvPr id="2" name="TextBox 1"/>
+          <p:cNvSpPr txBox="1"/>
+          <p:nvPr/>
+        </p:nvSpPr>
+        <p:spPr>
+          <a:xfrm>
+            <a:off x="320040" y="164592"/>
+            <a:ext cx="11521440" cy="548640"/>
+          </a:xfrm>
+          <a:prstGeom prst="rect">
+            <a:avLst/>
+          </a:prstGeom>
+          <a:noFill/>
+        </p:spPr>
+        <p:txBody>
+          <a:bodyPr wrap="none">
+            <a:spAutoFit/>
+          </a:bodyPr>
+          <a:lstStyle/>
+          <a:p>
+            <a:pPr>
+              <a:defRPr sz="2400" b="1"/>
+            </a:pPr>
+            <a:r>
+              <a:t>WD Method in Detail ② — Confirmation Stage (Physics Fitting): Blocks 5–6</a:t>
+            </a:r>
+          </a:p>
+        </p:txBody>
+      </p:sp>
+      <p:sp>
+        <p:nvSpPr>
+          <p:cNvPr id="3" name="TextBox 2"/>
+          <p:cNvSpPr txBox="1"/>
+          <p:nvPr/>
+        </p:nvSpPr>
+        <p:spPr>
+          <a:xfrm>
+            <a:off x="320040" y="713232"/>
+            <a:ext cx="11521440" cy="365760"/>
+          </a:xfrm>
+          <a:prstGeom prst="rect">
+            <a:avLst/>
+          </a:prstGeom>
+          <a:noFill/>
+        </p:spPr>
+        <p:txBody>
+          <a:bodyPr wrap="none">
+            <a:spAutoFit/>
+          </a:bodyPr>
+          <a:lstStyle/>
+          <a:p>
+            <a:pPr>
+              <a:defRPr sz="1300" b="1">
+                <a:solidFill>
+                  <a:srgbClr val="B45000"/>
+                </a:solidFill>
+              </a:defRPr>
+            </a:pPr>
+            <a:r>
+              <a:t>▶ Key idea: 'only inside the network-proposed regions, physics formulas and statistics finalize even the count'</a:t>
+            </a:r>
+          </a:p>
+        </p:txBody>
+      </p:sp>
+      <p:sp>
+        <p:nvSpPr>
+          <p:cNvPr id="4" name="Rounded Rectangle 3"/>
+          <p:cNvSpPr/>
+          <p:nvPr/>
+        </p:nvSpPr>
+        <p:spPr>
+          <a:xfrm>
+            <a:off x="320040" y="1188720"/>
+            <a:ext cx="2816352" cy="5029200"/>
+          </a:xfrm>
+          <a:prstGeom prst="roundRect">
+            <a:avLst/>
+          </a:prstGeom>
+          <a:solidFill>
+            <a:srgbClr val="EADCF8"/>
+          </a:solidFill>
+          <a:ln>
+            <a:solidFill>
+              <a:srgbClr val="666666"/>
+            </a:solidFill>
+          </a:ln>
+        </p:spPr>
+        <p:style>
+          <a:lnRef idx="1">
+            <a:schemeClr val="accent1"/>
+          </a:lnRef>
+          <a:fillRef idx="3">
+            <a:schemeClr val="accent1"/>
+          </a:fillRef>
+          <a:effectRef idx="2">
+            <a:schemeClr val="accent1"/>
+          </a:effectRef>
+          <a:fontRef idx="minor">
+            <a:schemeClr val="lt1"/>
+          </a:fontRef>
+        </p:style>
+        <p:txBody>
+          <a:bodyPr rtlCol="0" anchor="ctr" wrap="square" lIns="73152" rIns="73152" tIns="36576" bIns="36576"/>
+          <a:lstStyle/>
+          <a:p>
+            <a:pPr algn="l">
+              <a:defRPr sz="1200" b="1">
+                <a:solidFill>
+                  <a:srgbClr val="1A1A1A"/>
+                </a:solidFill>
+              </a:defRPr>
+            </a:pPr>
+            <a:r>
+              <a:t>⑤-1  Region-constrained RJMCMC — 3 moves</a:t>
+            </a:r>
+          </a:p>
+          <a:p>
+            <a:pPr>
+              <a:defRPr sz="950">
+                <a:solidFill>
+                  <a:srgbClr val="262626"/>
+                </a:solidFill>
+              </a:defRPr>
+            </a:pPr>
+            <a:r>
+              <a:t>birth: propose a new spin (A,B) only inside PF regions (20%)</a:t>
+            </a:r>
+          </a:p>
+          <a:p>
+            <a:pPr>
+              <a:defRPr sz="950">
+                <a:solidFill>
+                  <a:srgbClr val="262626"/>
+                </a:solidFill>
+              </a:defRPr>
+            </a:pPr>
+            <a:r>
+              <a:t>death: try removing an existing spin (20%)</a:t>
+            </a:r>
+          </a:p>
+          <a:p>
+            <a:pPr>
+              <a:defRPr sz="950">
+                <a:solidFill>
+                  <a:srgbClr val="262626"/>
+                </a:solidFill>
+              </a:defRPr>
+            </a:pPr>
+            <a:r>
+              <a:t>perturb: keep count, nudge A±2 kHz · B±5 kHz (60%)</a:t>
+            </a:r>
+          </a:p>
+          <a:p>
+            <a:pPr>
+              <a:defRPr sz="950">
+                <a:solidFill>
+                  <a:srgbClr val="262626"/>
+                </a:solidFill>
+              </a:defRPr>
+            </a:pPr>
+            <a:r>
+              <a:t>Out-of-region proposals rejected → search volume shrinks</a:t>
+            </a:r>
+          </a:p>
+          <a:p>
+            <a:pPr>
+              <a:defRPr sz="950">
+                <a:solidFill>
+                  <a:srgbClr val="262626"/>
+                </a:solidFill>
+              </a:defRPr>
+            </a:pPr>
+            <a:r>
+              <a:t>tens-fold = speed and accuracy at once</a:t>
+            </a:r>
+          </a:p>
+        </p:txBody>
+      </p:sp>
+      <p:sp>
+        <p:nvSpPr>
+          <p:cNvPr id="5" name="Right Arrow 4"/>
+          <p:cNvSpPr/>
+          <p:nvPr/>
+        </p:nvSpPr>
+        <p:spPr>
+          <a:xfrm>
+            <a:off x="3127248" y="3611879"/>
+            <a:ext cx="128015" cy="182880"/>
+          </a:xfrm>
+          <a:prstGeom prst="rightArrow">
+            <a:avLst/>
+          </a:prstGeom>
+          <a:solidFill>
+            <a:srgbClr val="888888"/>
+          </a:solidFill>
+          <a:ln>
+            <a:noFill/>
+          </a:ln>
+        </p:spPr>
+        <p:style>
+          <a:lnRef idx="1">
+            <a:schemeClr val="accent1"/>
+          </a:lnRef>
+          <a:fillRef idx="3">
+            <a:schemeClr val="accent1"/>
+          </a:fillRef>
+          <a:effectRef idx="2">
+            <a:schemeClr val="accent1"/>
+          </a:effectRef>
+          <a:fontRef idx="minor">
+            <a:schemeClr val="lt1"/>
+          </a:fontRef>
+        </p:style>
+        <p:txBody>
+          <a:bodyPr rtlCol="0" anchor="ctr"/>
+          <a:lstStyle/>
+          <a:p>
+            <a:pPr algn="ctr"/>
+          </a:p>
+        </p:txBody>
+      </p:sp>
+      <p:sp>
+        <p:nvSpPr>
+          <p:cNvPr id="6" name="Rounded Rectangle 5"/>
+          <p:cNvSpPr/>
+          <p:nvPr/>
+        </p:nvSpPr>
+        <p:spPr>
+          <a:xfrm>
+            <a:off x="3246120" y="1188720"/>
+            <a:ext cx="2816352" cy="5029200"/>
+          </a:xfrm>
+          <a:prstGeom prst="roundRect">
+            <a:avLst/>
+          </a:prstGeom>
+          <a:solidFill>
+            <a:srgbClr val="EADCF8"/>
+          </a:solidFill>
+          <a:ln>
+            <a:solidFill>
+              <a:srgbClr val="666666"/>
+            </a:solidFill>
+          </a:ln>
+        </p:spPr>
+        <p:style>
+          <a:lnRef idx="1">
+            <a:schemeClr val="accent1"/>
+          </a:lnRef>
+          <a:fillRef idx="3">
+            <a:schemeClr val="accent1"/>
+          </a:fillRef>
+          <a:effectRef idx="2">
+            <a:schemeClr val="accent1"/>
+          </a:effectRef>
+          <a:fontRef idx="minor">
+            <a:schemeClr val="lt1"/>
+          </a:fontRef>
+        </p:style>
+        <p:txBody>
+          <a:bodyPr rtlCol="0" anchor="ctr" wrap="square" lIns="73152" rIns="73152" tIns="36576" bIns="36576"/>
+          <a:lstStyle/>
+          <a:p>
+            <a:pPr algn="l">
+              <a:defRPr sz="1200" b="1">
+                <a:solidFill>
+                  <a:srgbClr val="1A1A1A"/>
+                </a:solidFill>
+              </a:defRPr>
+            </a:pPr>
+            <a:r>
+              <a:t>⑤-2  Acceptance rule — the 'rent' test</a:t>
+            </a:r>
+          </a:p>
+          <a:p>
+            <a:pPr>
+              <a:defRPr sz="950">
+                <a:solidFill>
+                  <a:srgbClr val="262626"/>
+                </a:solidFill>
+              </a:defRPr>
+            </a:pPr>
+            <a:r>
+              <a:t>Objective: −2lnπ = SSE/σ² + 2k·ln(n)   (n = 3 channels × 700 pts)</a:t>
+            </a:r>
+          </a:p>
+          <a:p>
+            <a:pPr>
+              <a:defRPr sz="950">
+                <a:solidFill>
+                  <a:srgbClr val="262626"/>
+                </a:solidFill>
+              </a:defRPr>
+            </a:pPr>
+            <a:r>
+              <a:t>Accept prob = min(1, exp(−Δ/2T)) — always if better, else stochastic</a:t>
+            </a:r>
+          </a:p>
+          <a:p>
+            <a:pPr>
+              <a:defRPr sz="950">
+                <a:solidFill>
+                  <a:srgbClr val="262626"/>
+                </a:solidFill>
+              </a:defRPr>
+            </a:pPr>
+            <a:r>
+              <a:t>A new spin must pay rent 2ln(n)≈15.3 in residual reduction to survive</a:t>
+            </a:r>
+          </a:p>
+          <a:p>
+            <a:pPr>
+              <a:defRPr sz="950">
+                <a:solidFill>
+                  <a:srgbClr val="262626"/>
+                </a:solidFill>
+              </a:defRPr>
+            </a:pPr>
+            <a:r>
+              <a:t>Annealing T: 20→1 (broad early exploration → strict settling)</a:t>
+            </a:r>
+          </a:p>
+          <a:p>
+            <a:pPr>
+              <a:defRPr sz="950">
+                <a:solidFill>
+                  <a:srgbClr val="262626"/>
+                </a:solidFill>
+              </a:defRPr>
+            </a:pPr>
+            <a:r>
+              <a:t>Joint 3-channel residual → single-channel-only fits die out</a:t>
+            </a:r>
+          </a:p>
+        </p:txBody>
+      </p:sp>
+      <p:sp>
+        <p:nvSpPr>
+          <p:cNvPr id="7" name="Right Arrow 6"/>
+          <p:cNvSpPr/>
+          <p:nvPr/>
+        </p:nvSpPr>
+        <p:spPr>
+          <a:xfrm>
+            <a:off x="6053328" y="3611879"/>
+            <a:ext cx="128015" cy="182880"/>
+          </a:xfrm>
+          <a:prstGeom prst="rightArrow">
+            <a:avLst/>
+          </a:prstGeom>
+          <a:solidFill>
+            <a:srgbClr val="888888"/>
+          </a:solidFill>
+          <a:ln>
+            <a:noFill/>
+          </a:ln>
+        </p:spPr>
+        <p:style>
+          <a:lnRef idx="1">
+            <a:schemeClr val="accent1"/>
+          </a:lnRef>
+          <a:fillRef idx="3">
+            <a:schemeClr val="accent1"/>
+          </a:fillRef>
+          <a:effectRef idx="2">
+            <a:schemeClr val="accent1"/>
+          </a:effectRef>
+          <a:fontRef idx="minor">
+            <a:schemeClr val="lt1"/>
+          </a:fontRef>
+        </p:style>
+        <p:txBody>
+          <a:bodyPr rtlCol="0" anchor="ctr"/>
+          <a:lstStyle/>
+          <a:p>
+            <a:pPr algn="ctr"/>
+          </a:p>
+        </p:txBody>
+      </p:sp>
+      <p:sp>
+        <p:nvSpPr>
+          <p:cNvPr id="8" name="Rounded Rectangle 7"/>
+          <p:cNvSpPr/>
+          <p:nvPr/>
+        </p:nvSpPr>
+        <p:spPr>
+          <a:xfrm>
+            <a:off x="6172200" y="1188720"/>
+            <a:ext cx="2816352" cy="5029200"/>
+          </a:xfrm>
+          <a:prstGeom prst="roundRect">
+            <a:avLst/>
+          </a:prstGeom>
+          <a:solidFill>
+            <a:srgbClr val="F2D5CC"/>
+          </a:solidFill>
+          <a:ln>
+            <a:solidFill>
+              <a:srgbClr val="666666"/>
+            </a:solidFill>
+          </a:ln>
+        </p:spPr>
+        <p:style>
+          <a:lnRef idx="1">
+            <a:schemeClr val="accent1"/>
+          </a:lnRef>
+          <a:fillRef idx="3">
+            <a:schemeClr val="accent1"/>
+          </a:fillRef>
+          <a:effectRef idx="2">
+            <a:schemeClr val="accent1"/>
+          </a:effectRef>
+          <a:fontRef idx="minor">
+            <a:schemeClr val="lt1"/>
+          </a:fontRef>
+        </p:style>
+        <p:txBody>
+          <a:bodyPr rtlCol="0" anchor="ctr" wrap="square" lIns="73152" rIns="73152" tIns="36576" bIns="36576"/>
+          <a:lstStyle/>
+          <a:p>
+            <a:pPr algn="l">
+              <a:defRPr sz="1200" b="1">
+                <a:solidFill>
+                  <a:srgbClr val="1A1A1A"/>
+                </a:solidFill>
+              </a:defRPr>
+            </a:pPr>
+            <a:r>
+              <a:t>⑤-3  Deciding the count — double check</a:t>
+            </a:r>
+          </a:p>
+          <a:p>
+            <a:pPr>
+              <a:defRPr sz="950">
+                <a:solidFill>
+                  <a:srgbClr val="262626"/>
+                </a:solidFill>
+              </a:defRPr>
+            </a:pPr>
+            <a:r>
+              <a:t>BIC trace over k=1,2,…: minimum at k*=14 (NV1)</a:t>
+            </a:r>
+          </a:p>
+          <a:p>
+            <a:pPr>
+              <a:defRPr sz="950">
+                <a:solidFill>
+                  <a:srgbClr val="262626"/>
+                </a:solidFill>
+              </a:defRPr>
+            </a:pPr>
+            <a:r>
+              <a:t>RJMCMC posterior P(k|data): mode 15</a:t>
+            </a:r>
+          </a:p>
+          <a:p>
+            <a:pPr>
+              <a:defRPr sz="950">
+                <a:solidFill>
+                  <a:srgbClr val="262626"/>
+                </a:solidFill>
+              </a:defRPr>
+            </a:pPr>
+            <a:r>
+              <a:t>Two independent procedures, same answer (14±1)</a:t>
+            </a:r>
+          </a:p>
+          <a:p>
+            <a:pPr>
+              <a:defRPr sz="950">
+                <a:solidFill>
+                  <a:srgbClr val="262626"/>
+                </a:solidFill>
+              </a:defRPr>
+            </a:pPr>
+            <a:r>
+              <a:t>Output: MAP spin list {(A∥,A⊥)}×k*</a:t>
+            </a:r>
+          </a:p>
+        </p:txBody>
+      </p:sp>
+      <p:sp>
+        <p:nvSpPr>
+          <p:cNvPr id="9" name="Right Arrow 8"/>
+          <p:cNvSpPr/>
+          <p:nvPr/>
+        </p:nvSpPr>
+        <p:spPr>
+          <a:xfrm>
+            <a:off x="8979408" y="3611879"/>
+            <a:ext cx="128015" cy="182880"/>
+          </a:xfrm>
+          <a:prstGeom prst="rightArrow">
+            <a:avLst/>
+          </a:prstGeom>
+          <a:solidFill>
+            <a:srgbClr val="888888"/>
+          </a:solidFill>
+          <a:ln>
+            <a:noFill/>
+          </a:ln>
+        </p:spPr>
+        <p:style>
+          <a:lnRef idx="1">
+            <a:schemeClr val="accent1"/>
+          </a:lnRef>
+          <a:fillRef idx="3">
+            <a:schemeClr val="accent1"/>
+          </a:fillRef>
+          <a:effectRef idx="2">
+            <a:schemeClr val="accent1"/>
+          </a:effectRef>
+          <a:fontRef idx="minor">
+            <a:schemeClr val="lt1"/>
+          </a:fontRef>
+        </p:style>
+        <p:txBody>
+          <a:bodyPr rtlCol="0" anchor="ctr"/>
+          <a:lstStyle/>
+          <a:p>
+            <a:pPr algn="ctr"/>
+          </a:p>
+        </p:txBody>
+      </p:sp>
+      <p:sp>
+        <p:nvSpPr>
+          <p:cNvPr id="10" name="Rounded Rectangle 9"/>
+          <p:cNvSpPr/>
+          <p:nvPr/>
+        </p:nvSpPr>
+        <p:spPr>
+          <a:xfrm>
+            <a:off x="9098280" y="1188720"/>
+            <a:ext cx="2816352" cy="5029200"/>
+          </a:xfrm>
+          <a:prstGeom prst="roundRect">
+            <a:avLst/>
+          </a:prstGeom>
+          <a:solidFill>
+            <a:srgbClr val="D9EAD3"/>
+          </a:solidFill>
+          <a:ln>
+            <a:solidFill>
+              <a:srgbClr val="666666"/>
+            </a:solidFill>
+          </a:ln>
+        </p:spPr>
+        <p:style>
+          <a:lnRef idx="1">
+            <a:schemeClr val="accent1"/>
+          </a:lnRef>
+          <a:fillRef idx="3">
+            <a:schemeClr val="accent1"/>
+          </a:fillRef>
+          <a:effectRef idx="2">
+            <a:schemeClr val="accent1"/>
+          </a:effectRef>
+          <a:fontRef idx="minor">
+            <a:schemeClr val="lt1"/>
+          </a:fontRef>
+        </p:style>
+        <p:txBody>
+          <a:bodyPr rtlCol="0" anchor="ctr" wrap="square" lIns="73152" rIns="73152" tIns="36576" bIns="36576"/>
+          <a:lstStyle/>
+          <a:p>
+            <a:pPr algn="l">
+              <a:defRPr sz="1200" b="1">
+                <a:solidFill>
+                  <a:srgbClr val="1A1A1A"/>
+                </a:solidFill>
+              </a:defRPr>
+            </a:pPr>
+            <a:r>
+              <a:t>⑥  Final list + 95% CI</a:t>
+            </a:r>
+          </a:p>
+          <a:p>
+            <a:pPr>
+              <a:defRPr sz="950">
+                <a:solidFill>
+                  <a:srgbClr val="262626"/>
+                </a:solidFill>
+              </a:defRPr>
+            </a:pPr>
+            <a:r>
+              <a:t>Residual bootstrap, 60 refits → error bars (95% CI) per (A∥,A⊥)</a:t>
+            </a:r>
+          </a:p>
+          <a:p>
+            <a:pPr>
+              <a:defRPr sz="950">
+                <a:solidFill>
+                  <a:srgbClr val="262626"/>
+                </a:solidFill>
+              </a:defRPr>
+            </a:pPr>
+            <a:r>
+              <a:t>Non-overlapping CIs = statistically distinct entities</a:t>
+            </a:r>
+          </a:p>
+          <a:p>
+            <a:pPr>
+              <a:defRPr sz="950">
+                <a:solidFill>
+                  <a:srgbClr val="262626"/>
+                </a:solidFill>
+              </a:defRPr>
+            </a:pPr>
+            <a:r>
+              <a:t>Checks: anchors 7/7 recovered · NV1 three measurements</a:t>
+            </a:r>
+          </a:p>
+          <a:p>
+            <a:pPr>
+              <a:defRPr sz="950">
+                <a:solidFill>
+                  <a:srgbClr val="262626"/>
+                </a:solidFill>
+              </a:defRPr>
+            </a:pPr>
+            <a:r>
+              <a:t>reproduced simultaneously, RMSE 0.088–0.176</a:t>
+            </a:r>
+          </a:p>
+          <a:p>
+            <a:pPr>
+              <a:defRPr sz="950">
+                <a:solidFill>
+                  <a:srgbClr val="262626"/>
+                </a:solidFill>
+              </a:defRPr>
+            </a:pPr>
+            <a:r>
+              <a:t>Final: NV1 14 · NV2 9 + 1 withheld</a:t>
+            </a:r>
+          </a:p>
+        </p:txBody>
+      </p:sp>
+      <p:sp>
+        <p:nvSpPr>
+          <p:cNvPr id="11" name="TextBox 10"/>
+          <p:cNvSpPr txBox="1"/>
+          <p:nvPr/>
+        </p:nvSpPr>
+        <p:spPr>
+          <a:xfrm>
+            <a:off x="320040" y="6419088"/>
+            <a:ext cx="11521440" cy="384048"/>
+          </a:xfrm>
+          <a:prstGeom prst="rect">
+            <a:avLst/>
+          </a:prstGeom>
+          <a:noFill/>
+        </p:spPr>
+        <p:txBody>
+          <a:bodyPr wrap="square">
+            <a:spAutoFit/>
+          </a:bodyPr>
+          <a:lstStyle/>
+          <a:p>
+            <a:pPr>
+              <a:defRPr sz="1000">
+                <a:solidFill>
+                  <a:srgbClr val="404040"/>
+                </a:solidFill>
+              </a:defRPr>
+            </a:pPr>
+            <a:r>
+              <a:t>Block ⑤ in one line: the network's intuition (regions) is finalized by the referee of physics (forward-model residual + statistical penalty)</a:t>
+            </a:r>
+          </a:p>
+        </p:txBody>
+      </p:sp>
+    </p:spTree>
+  </p:cSld>
+  <p:clrMapOvr>
+    <a:masterClrMapping/>
+  </p:clrMapOvr>
+</p:sld>
+</file>
+
+<file path=ppt/slides/slide12.xml><?xml version="1.0" encoding="utf-8"?>
+<p:sld xmlns:a="http://schemas.openxmlformats.org/drawingml/2006/main" xmlns:p="http://schemas.openxmlformats.org/presentationml/2006/main" xmlns:r="http://schemas.openxmlformats.org/officeDocument/2006/relationships">
+  <p:cSld>
+    <p:spTree>
+      <p:nvGrpSpPr>
+        <p:cNvPr id="1" name=""/>
+        <p:cNvGrpSpPr/>
+        <p:nvPr/>
+      </p:nvGrpSpPr>
+      <p:grpSpPr/>
+      <p:sp>
+        <p:nvSpPr>
+          <p:cNvPr id="2" name="TextBox 1"/>
+          <p:cNvSpPr txBox="1"/>
+          <p:nvPr/>
+        </p:nvSpPr>
+        <p:spPr>
+          <a:xfrm>
+            <a:off x="320040" y="164592"/>
+            <a:ext cx="11521440" cy="548640"/>
+          </a:xfrm>
+          <a:prstGeom prst="rect">
+            <a:avLst/>
+          </a:prstGeom>
+          <a:noFill/>
+        </p:spPr>
+        <p:txBody>
+          <a:bodyPr wrap="none">
+            <a:spAutoFit/>
+          </a:bodyPr>
+          <a:lstStyle/>
+          <a:p>
+            <a:pPr>
+              <a:defRPr sz="2400" b="1"/>
+            </a:pPr>
+            <a:r>
+              <a:t>Related Work — Poteshman et al. (with Taminiau group, Quantum 2026)</a:t>
+            </a:r>
+          </a:p>
+        </p:txBody>
+      </p:sp>
+      <p:sp>
+        <p:nvSpPr>
+          <p:cNvPr id="3" name="TextBox 2"/>
+          <p:cNvSpPr txBox="1"/>
+          <p:nvPr/>
+        </p:nvSpPr>
+        <p:spPr>
+          <a:xfrm>
+            <a:off x="320040" y="713232"/>
+            <a:ext cx="11521440" cy="365760"/>
+          </a:xfrm>
+          <a:prstGeom prst="rect">
+            <a:avLst/>
+          </a:prstGeom>
+          <a:noFill/>
+        </p:spPr>
+        <p:txBody>
+          <a:bodyPr wrap="none">
+            <a:spAutoFit/>
+          </a:bodyPr>
+          <a:lstStyle/>
+          <a:p>
+            <a:pPr>
+              <a:defRPr sz="1300" b="1">
+                <a:solidFill>
+                  <a:srgbClr val="B45000"/>
+                </a:solidFill>
+              </a:defRPr>
+            </a:pPr>
+            <a:r>
+              <a:t>▶ An independent contemporary study reaches the same conclusion (trans-dimensional Bayesian is the right tool) — the difference is what narrows the search: DFT lattice vs learned attention</a:t>
+            </a:r>
+          </a:p>
+        </p:txBody>
+      </p:sp>
+      <p:graphicFrame>
+        <p:nvGraphicFramePr>
+          <p:cNvPr id="4" name="Table 3"/>
+          <p:cNvGraphicFramePr>
+            <a:graphicFrameLocks noGrp="1"/>
+          </p:cNvGraphicFramePr>
+          <p:nvPr/>
+        </p:nvGraphicFramePr>
+        <p:xfrm>
+          <a:off x="320040" y="1188720"/>
+          <a:ext cx="11475720" cy="4937760"/>
+        </p:xfrm>
+        <a:graphic>
+          <a:graphicData uri="http://schemas.openxmlformats.org/drawingml/2006/table">
+            <a:tbl>
+              <a:tblPr firstRow="1" bandRow="1">
+                <a:tableStyleId>{5C22544A-7EE6-4342-B048-85BDC9FD1C3A}</a:tableStyleId>
+              </a:tblPr>
+              <a:tblGrid>
+                <a:gridCol w="1234440"/>
+                <a:gridCol w="5120640"/>
+                <a:gridCol w="5120640"/>
+              </a:tblGrid>
+              <a:tr h="822960">
+                <a:tc>
+                  <a:txBody>
+                    <a:bodyPr/>
+                    <a:lstStyle/>
+                    <a:p>
+                      <a:pPr>
+                        <a:defRPr sz="1100" b="1"/>
+                      </a:pPr>
+                      <a:r>
+                        <a:t>Aspect</a:t>
+                      </a:r>
+                    </a:p>
+                  </a:txBody>
+                  <a:tcPr>
+                    <a:solidFill>
+                      <a:srgbClr val="EEEEEE"/>
+                    </a:solidFill>
+                  </a:tcPr>
+                </a:tc>
+                <a:tc>
+                  <a:txBody>
+                    <a:bodyPr/>
+                    <a:lstStyle/>
+                    <a:p>
+                      <a:pPr>
+                        <a:defRPr sz="1100" b="1"/>
+                      </a:pPr>
+                      <a:r>
+                        <a:t>Poteshman 2026 (hybrid MCMC)</a:t>
+                      </a:r>
+                    </a:p>
+                    <a:p>
+                      <a:pPr>
+                        <a:defRPr sz="1100" b="1"/>
+                      </a:pPr>
+                      <a:r>
+                        <a:t>arXiv 2506.18802 · published in Quantum</a:t>
+                      </a:r>
+                    </a:p>
+                  </a:txBody>
+                  <a:tcPr>
+                    <a:solidFill>
+                      <a:srgbClr val="F2D5CC"/>
+                    </a:solidFill>
+                  </a:tcPr>
+                </a:tc>
+                <a:tc>
+                  <a:txBody>
+                    <a:bodyPr/>
+                    <a:lstStyle/>
+                    <a:p>
+                      <a:pPr>
+                        <a:defRPr sz="1100" b="1"/>
+                      </a:pPr>
+                      <a:r>
+                        <a:t>WD method (PF→RJMCMC hybrid v2)</a:t>
+                      </a:r>
+                    </a:p>
+                  </a:txBody>
+                  <a:tcPr>
+                    <a:solidFill>
+                      <a:srgbClr val="D9EAD3"/>
+                    </a:solidFill>
+                  </a:tcPr>
+                </a:tc>
+              </a:tr>
+              <a:tr h="822960">
+                <a:tc>
+                  <a:txBody>
+                    <a:bodyPr/>
+                    <a:lstStyle/>
+                    <a:p>
+                      <a:pPr>
+                        <a:defRPr sz="950" b="1"/>
+                      </a:pPr>
+                      <a:r>
+                        <a:t>Search proposal</a:t>
+                      </a:r>
+                    </a:p>
+                    <a:p>
+                      <a:pPr>
+                        <a:defRPr sz="950" b="1"/>
+                      </a:pPr>
+                      <a:r>
+                        <a:t>(prior)</a:t>
+                      </a:r>
+                    </a:p>
+                  </a:txBody>
+                  <a:tcPr/>
+                </a:tc>
+                <a:tc>
+                  <a:txBody>
+                    <a:bodyPr/>
+                    <a:lstStyle/>
+                    <a:p>
+                      <a:pPr>
+                        <a:defRPr sz="950" b="0"/>
+                      </a:pPr>
+                      <a:r>
+                        <a:t>DFT lattice discretization — search only over computed</a:t>
+                      </a:r>
+                    </a:p>
+                    <a:p>
+                      <a:pPr>
+                        <a:defRPr sz="950" b="0"/>
+                      </a:pPr>
+                      <a:r>
+                        <a:t>hyperfine values at 3,518 diamond lattice sites (|A|&gt;5 kHz)</a:t>
+                      </a:r>
+                    </a:p>
+                  </a:txBody>
+                  <a:tcPr/>
+                </a:tc>
+                <a:tc>
+                  <a:txBody>
+                    <a:bodyPr/>
+                    <a:lstStyle/>
+                    <a:p>
+                      <a:pPr>
+                        <a:defRPr sz="950" b="0"/>
+                      </a:pPr>
+                      <a:r>
+                        <a:t>Candidate regions from a learned attention detector (PF) —</a:t>
+                      </a:r>
+                    </a:p>
+                    <a:p>
+                      <a:pPr>
+                        <a:defRPr sz="950" b="0"/>
+                      </a:pPr>
+                      <a:r>
+                        <a:t>no DFT/lattice info needed, proposed from data</a:t>
+                      </a:r>
+                    </a:p>
+                  </a:txBody>
+                  <a:tcPr/>
+                </a:tc>
+              </a:tr>
+              <a:tr h="822960">
+                <a:tc>
+                  <a:txBody>
+                    <a:bodyPr/>
+                    <a:lstStyle/>
+                    <a:p>
+                      <a:pPr>
+                        <a:defRPr sz="950" b="1"/>
+                      </a:pPr>
+                      <a:r>
+                        <a:t>Engine</a:t>
+                      </a:r>
+                    </a:p>
+                  </a:txBody>
+                  <a:tcPr/>
+                </a:tc>
+                <a:tc>
+                  <a:txBody>
+                    <a:bodyPr/>
+                    <a:lstStyle/>
+                    <a:p>
+                      <a:pPr>
+                        <a:defRPr sz="950" b="0"/>
+                      </a:pPr>
+                      <a:r>
+                        <a:t>RJMCMC + parallel tempering (10 replicas) + RWMH cycle</a:t>
+                      </a:r>
+                    </a:p>
+                    <a:p>
+                      <a:pPr>
+                        <a:defRPr sz="950" b="0"/>
+                      </a:pPr>
+                      <a:r>
+                        <a:t>(50/100/25-step cycles, 5 ensembles × 25,000 steps)</a:t>
+                      </a:r>
+                    </a:p>
+                  </a:txBody>
+                  <a:tcPr/>
+                </a:tc>
+                <a:tc>
+                  <a:txBody>
+                    <a:bodyPr/>
+                    <a:lstStyle/>
+                    <a:p>
+                      <a:pPr>
+                        <a:defRPr sz="950" b="0"/>
+                      </a:pPr>
+                      <a:r>
+                        <a:t>Region-constrained RJMCMC (birth/death/perturb) + annealing</a:t>
+                      </a:r>
+                    </a:p>
+                    <a:p>
+                      <a:pPr>
+                        <a:defRPr sz="950" b="0"/>
+                      </a:pPr>
+                      <a:r>
+                        <a:t>+ independent BIC cross-check</a:t>
+                      </a:r>
+                    </a:p>
+                  </a:txBody>
+                  <a:tcPr/>
+                </a:tc>
+              </a:tr>
+              <a:tr h="822960">
+                <a:tc>
+                  <a:txBody>
+                    <a:bodyPr/>
+                    <a:lstStyle/>
+                    <a:p>
+                      <a:pPr>
+                        <a:defRPr sz="950" b="1"/>
+                      </a:pPr>
+                      <a:r>
+                        <a:t>Decay · data</a:t>
+                      </a:r>
+                    </a:p>
+                  </a:txBody>
+                  <a:tcPr/>
+                </a:tc>
+                <a:tc>
+                  <a:txBody>
+                    <a:bodyPr/>
+                    <a:lstStyle/>
+                    <a:p>
+                      <a:pPr>
+                        <a:defRPr sz="950" b="0"/>
+                      </a:pPr>
+                      <a:r>
+                        <a:t>decay λ co-estimated inside the likelihood</a:t>
+                      </a:r>
+                    </a:p>
+                    <a:p>
+                      <a:pPr>
+                        <a:defRPr sz="950" b="0"/>
+                      </a:pPr>
+                      <a:r>
+                        <a:t>cryo 3.7 K · N=32 single channel · τ 6–8 µs, 250 pts</a:t>
+                      </a:r>
+                    </a:p>
+                  </a:txBody>
+                  <a:tcPr/>
+                </a:tc>
+                <a:tc>
+                  <a:txBody>
+                    <a:bodyPr/>
+                    <a:lstStyle/>
+                    <a:p>
+                      <a:pPr>
+                        <a:defRPr sz="950" b="0"/>
+                      </a:pPr>
+                      <a:r>
+                        <a:t>stretched-exp envelope pre-normalization (Eq.5)</a:t>
+                      </a:r>
+                    </a:p>
+                    <a:p>
+                      <a:pPr>
+                        <a:defRPr sz="950" b="0"/>
+                      </a:pPr>
+                      <a:r>
+                        <a:t>room temp · N=8/16/20 three channels jointly · 700 pts</a:t>
+                      </a:r>
+                    </a:p>
+                  </a:txBody>
+                  <a:tcPr/>
+                </a:tc>
+              </a:tr>
+              <a:tr h="822960">
+                <a:tc>
+                  <a:txBody>
+                    <a:bodyPr/>
+                    <a:lstStyle/>
+                    <a:p>
+                      <a:pPr>
+                        <a:defRPr sz="950" b="1"/>
+                      </a:pPr>
+                      <a:r>
+                        <a:t>Results</a:t>
+                      </a:r>
+                    </a:p>
+                  </a:txBody>
+                  <a:tcPr/>
+                </a:tc>
+                <a:tc>
+                  <a:txBody>
+                    <a:bodyPr/>
+                    <a:lstStyle/>
+                    <a:p>
+                      <a:pPr>
+                        <a:defRPr sz="950" b="0"/>
+                      </a:pPr>
+                      <a:r>
+                        <a:t>modal k=46 (ref. 50) · 45 of 48 spins in posterior</a:t>
+                      </a:r>
+                    </a:p>
+                    <a:p>
+                      <a:pPr>
+                        <a:defRPr sz="950" b="0"/>
+                      </a:pPr>
+                      <a:r>
+                        <a:t>1 strong spin (C36) missed — depends on DFT accuracy</a:t>
+                      </a:r>
+                    </a:p>
+                    <a:p>
+                      <a:pPr>
+                        <a:defRPr sz="950" b="0"/>
+                      </a:pPr>
+                      <a:r>
+                        <a:t>weak coupling &lt;25 kHz stated unresolved</a:t>
+                      </a:r>
+                    </a:p>
+                  </a:txBody>
+                  <a:tcPr/>
+                </a:tc>
+                <a:tc>
+                  <a:txBody>
+                    <a:bodyPr/>
+                    <a:lstStyle/>
+                    <a:p>
+                      <a:pPr>
+                        <a:defRPr sz="950" b="0"/>
+                      </a:pPr>
+                      <a:r>
+                        <a:t>twin F1: cryo 0.84 / room 0.57 / error-injected 0.61</a:t>
+                      </a:r>
+                    </a:p>
+                    <a:p>
+                      <a:pPr>
+                        <a:defRPr sz="950" b="0"/>
+                      </a:pPr>
+                      <a:r>
+                        <a:t>NV1 14 confirmed (95% CI) · anchors 7/7 recovered</a:t>
+                      </a:r>
+                    </a:p>
+                    <a:p>
+                      <a:pPr>
+                        <a:defRPr sz="950" b="0"/>
+                      </a:pPr>
+                      <a:r>
+                        <a:t>weak-coupling kHz band is the design target</a:t>
+                      </a:r>
+                    </a:p>
+                  </a:txBody>
+                  <a:tcPr/>
+                </a:tc>
+              </a:tr>
+              <a:tr h="822960">
+                <a:tc>
+                  <a:txBody>
+                    <a:bodyPr/>
+                    <a:lstStyle/>
+                    <a:p>
+                      <a:pPr>
+                        <a:defRPr sz="950" b="1"/>
+                      </a:pPr>
+                      <a:r>
+                        <a:t>Compute</a:t>
+                      </a:r>
+                    </a:p>
+                  </a:txBody>
+                  <a:tcPr/>
+                </a:tc>
+                <a:tc>
+                  <a:txBody>
+                    <a:bodyPr/>
+                    <a:lstStyle/>
+                    <a:p>
+                      <a:pPr>
+                        <a:defRPr sz="950" b="0"/>
+                      </a:pPr>
+                      <a:r>
+                        <a:t>~750k forward evaluations · 5 CPU cores, ~8 h · no training</a:t>
+                      </a:r>
+                    </a:p>
+                  </a:txBody>
+                  <a:tcPr/>
+                </a:tc>
+                <a:tc>
+                  <a:txBody>
+                    <a:bodyPr/>
+                    <a:lstStyle/>
+                    <a:p>
+                      <a:pPr>
+                        <a:defRPr sz="950" b="0"/>
+                      </a:pPr>
+                      <a:r>
+                        <a:t>PF trained once (GPU, tens of min; reused per condition)</a:t>
+                      </a:r>
+                    </a:p>
+                    <a:p>
+                      <a:pPr>
+                        <a:defRPr sz="950" b="0"/>
+                      </a:pPr>
+                      <a:r>
+                        <a:t>+ RJMCMC in minutes</a:t>
+                      </a:r>
+                    </a:p>
+                  </a:txBody>
+                  <a:tcPr/>
+                </a:tc>
+              </a:tr>
+            </a:tbl>
+          </a:graphicData>
+        </a:graphic>
+      </p:graphicFrame>
+      <p:sp>
+        <p:nvSpPr>
+          <p:cNvPr id="5" name="TextBox 4"/>
+          <p:cNvSpPr txBox="1"/>
+          <p:nvPr/>
+        </p:nvSpPr>
+        <p:spPr>
+          <a:xfrm>
+            <a:off x="320040" y="6272784"/>
+            <a:ext cx="11521440" cy="384048"/>
+          </a:xfrm>
+          <a:prstGeom prst="rect">
+            <a:avLst/>
+          </a:prstGeom>
+          <a:noFill/>
+        </p:spPr>
+        <p:txBody>
+          <a:bodyPr wrap="square">
+            <a:spAutoFit/>
+          </a:bodyPr>
+          <a:lstStyle/>
+          <a:p>
+            <a:pPr>
+              <a:defRPr sz="950">
+                <a:solidFill>
+                  <a:srgbClr val="404040"/>
+                </a:solidFill>
+              </a:defRPr>
+            </a:pPr>
+            <a:r>
+              <a:t>Companion paper arXiv 2506.19259 (Poteshman et al.): a high-throughput spin-defect characterization framework — the arena our automated pipeline targets. Both will be cited: contemporary work independently validating the direction, while room-temperature operation, multi-channel input, learned proposals, and a completed list with CIs remain our contributions.</a:t>
+            </a:r>
+          </a:p>
+        </p:txBody>
+      </p:sp>
+    </p:spTree>
   </p:cSld>
   <p:clrMapOvr>
     <a:masterClrMapping/>

</xml_diff>